<commit_message>
Switch Study Buddy to OpenAI for answers and embeddings
- Chat model: openai:gpt-5.4-mini by default (gpt-5.4 for the Lesson 8
  comparison). Reasoning is switched off for OpenAI so TEMPERATURE=0 is
  actually honoured; prices, context window and cost tables recomputed.
- Embeddings: OpenAI text-embedding-3-small replaces Hugging Face's hosted
  model, which no longer works without paid credits. One key (OPENAI_API_KEY)
  now powers everything; HF_TOKEN and langchain-huggingface removed.
- Lesson 4 numbers re-measured (1,536 dimensions); cross-language demo now
  presented as a measured limitation, and English notes recommended.
- Lesson 4 rebuilds its vector stores from scratch, and the stale committed
  my_vector_db (old 384-dim index, crashed Lesson 4) is untracked and ignored.
- Docs, guides, slides and decks updated to match.

Co-Authored-By: Claude Opus 5.5 (1M context) <noreply@anthropic.com>
Claude-Session: https://claude.ai/code/session_0136vqZAYcWZiKopE5XJe7WN
</commit_message>
<xml_diff>
--- a/slides/Lesson 1 - Setup and Your First AI Call.pptx
+++ b/slides/Lesson 1 - Setup and Your First AI Call.pptx
@@ -8778,7 +8778,7 @@
                 </a:solidFill>
                 <a:latin typeface="Poppins SemiBold"/>
               </a:rPr>
-              <a:t>Revision notes, a subject you study, the rules of a game. Armenian, English or both.</a:t>
+              <a:t>Revision notes, a subject you study, the rules of a game. English works best.</a:t>
             </a:r>
           </a:p>
           <a:p>
@@ -12180,7 +12180,7 @@
                 </a:solidFill>
                 <a:latin typeface="Poppins"/>
               </a:rPr>
-              <a:t>Send a message to Claude. Look at what comes back.</a:t>
+              <a:t>Send a message to the AI. Look at what comes back.</a:t>
             </a:r>
           </a:p>
         </p:txBody>

</xml_diff>